<commit_message>
chore: security fixes (remove committed .env), MIT license, docs sync
</commit_message>
<xml_diff>
--- a/output/test_export.pptx
+++ b/output/test_export.pptx
@@ -1101,7 +1101,7 @@
         <p:spPr>
           <a:xfrm>
             <a:off x="548640" y="1051560"/>
-            <a:ext cx="10726278" cy="365760"/>
+            <a:ext cx="10726278" cy="274320"/>
           </a:xfrm>
           <a:prstGeom prst="rect">
             <a:avLst/>
@@ -1139,7 +1139,7 @@
         </p:nvSpPr>
         <p:spPr>
           <a:xfrm>
-            <a:off x="548640" y="1463040"/>
+            <a:off x="548640" y="1371600"/>
             <a:ext cx="2286000" cy="0"/>
           </a:xfrm>
           <a:prstGeom prst="line">
@@ -1162,8 +1162,8 @@
         </p:nvSpPr>
         <p:spPr>
           <a:xfrm>
-            <a:off x="731520" y="1783080"/>
-            <a:ext cx="10698480" cy="4343400"/>
+            <a:off x="731520" y="1691640"/>
+            <a:ext cx="10698480" cy="4434840"/>
           </a:xfrm>
           <a:prstGeom prst="rect">
             <a:avLst/>

</xml_diff>